<commit_message>
VPB HotStock: 5-slide deck and Word version of the script
- Deck goes to 5 slides: adds a half-year PBT chart (1H25, 2H25, 1H26, and
  the 22,443bn 2H26 needs to hit the 41,323bn plan) so the high 2H25 base
  is visible rather than only mentioned. Both charts now use explicit
  srgbClr fills instead of a themeOverride part.
- Adds HotStock_VPB_31July2026_script.docx: the broadcast script as a Word
  document with a header block, the 191-word text, the slide list and the
  pre-recording checks.
- Internal sheet: records the slide-4 derivations and flags that the
  22,443bn column is a plan requirement, not a MAS forecast.

Co-Authored-By: Claude Opus 5 <noreply@anthropic.com>
Claude-Session: https://claude.ai/code/session_01QPsxWfyBSmSQjUzo5EDnm5
</commit_message>
<xml_diff>
--- a/HotStock_VPB_31July2026.pptx
+++ b/HotStock_VPB_31July2026.pptx
@@ -11,6 +11,7 @@
     <p:sldId id="375" r:id="rId6"/>
     <p:sldId id="381" r:id="rId7"/>
     <p:sldId id="383" r:id="rId8"/>
+    <p:sldId id="385" r:id="rId17"/>
     <p:sldId id="378" r:id="rId10"/>
   </p:sldIdLst>
   <p:sldSz cx="10287000" cy="13716000"/>
@@ -147,7 +148,6 @@
   <c:date1904 val="0"/>
   <c:lang val="en-US"/>
   <c:roundedCorners val="0"/>
-  <c:clrMapOvr bg1="lt1" tx1="dk1" bg2="lt2" tx2="dk2" accent1="accent1" accent2="accent2" accent3="accent3" accent4="accent4" accent5="accent5" accent6="accent6" hlink="hlink" folHlink="folHlink"/>
   <c:chart>
     <c:title>
       <c:tx>
@@ -158,10 +158,7 @@
             <a:pPr>
               <a:defRPr sz="2000" b="0" i="0" u="none" strike="noStrike" kern="1200" spc="0" baseline="0">
                 <a:solidFill>
-                  <a:schemeClr val="tx1">
-                    <a:lumMod val="65000"/>
-                    <a:lumOff val="35000"/>
-                  </a:schemeClr>
+                  <a:srgbClr val="595959"/>
                 </a:solidFill>
                 <a:latin typeface="Noto Sans" panose="020B0502040504020204" pitchFamily="34" charset="0"/>
                 <a:ea typeface="Noto Sans" panose="020B0502040504020204" pitchFamily="34" charset="0"/>
@@ -198,10 +195,7 @@
           <a:pPr>
             <a:defRPr sz="2000" b="0" i="0" u="none" strike="noStrike" kern="1200" baseline="0">
               <a:solidFill>
-                <a:schemeClr val="tx1">
-                  <a:lumMod val="65000"/>
-                  <a:lumOff val="35000"/>
-                </a:schemeClr>
+                <a:srgbClr val="595959"/>
               </a:solidFill>
               <a:latin typeface="Noto Sans" panose="020B0502040504020204" pitchFamily="34" charset="0"/>
               <a:ea typeface="Noto Sans" panose="020B0502040504020204" pitchFamily="34" charset="0"/>
@@ -223,11 +217,19 @@
           <c:idx val="0"/>
           <c:order val="0"/>
           <c:tx>
-            <c:v>LNTT hợp nhất</c:v>
+            <c:strRef>
+              <c:f>Sheet1!$A$2</c:f>
+              <c:strCache>
+                <c:ptCount val="1"/>
+                <c:pt idx="0">
+                  <c:v>LNTT hợp nhất</c:v>
+                </c:pt>
+              </c:strCache>
+            </c:strRef>
           </c:tx>
           <c:spPr>
             <a:solidFill>
-              <a:schemeClr val="accent1"/>
+              <a:srgbClr val="F0B26B"/>
             </a:solidFill>
             <a:ln>
               <a:noFill/>
@@ -241,7 +243,7 @@
             <c:bubble3D val="0"/>
             <c:spPr>
               <a:solidFill>
-                <a:schemeClr val="accent1"/>
+                <a:srgbClr val="F0B26B"/>
               </a:solidFill>
               <a:ln>
                 <a:noFill/>
@@ -255,7 +257,7 @@
             <c:bubble3D val="0"/>
             <c:spPr>
               <a:solidFill>
-                <a:schemeClr val="accent1"/>
+                <a:srgbClr val="F0B26B"/>
               </a:solidFill>
               <a:ln>
                 <a:noFill/>
@@ -269,7 +271,7 @@
             <c:bubble3D val="0"/>
             <c:spPr>
               <a:solidFill>
-                <a:schemeClr val="accent1"/>
+                <a:srgbClr val="F0B26B"/>
               </a:solidFill>
               <a:ln>
                 <a:noFill/>
@@ -283,7 +285,7 @@
             <c:bubble3D val="0"/>
             <c:spPr>
               <a:solidFill>
-                <a:schemeClr val="accent1"/>
+                <a:srgbClr val="F0B26B"/>
               </a:solidFill>
               <a:ln>
                 <a:noFill/>
@@ -297,7 +299,7 @@
             <c:bubble3D val="0"/>
             <c:spPr>
               <a:solidFill>
-                <a:schemeClr val="accent3"/>
+                <a:srgbClr val="043B72"/>
               </a:solidFill>
               <a:ln>
                 <a:noFill/>
@@ -311,7 +313,7 @@
             <c:bubble3D val="0"/>
             <c:spPr>
               <a:solidFill>
-                <a:schemeClr val="accent3"/>
+                <a:srgbClr val="043B72"/>
               </a:solidFill>
               <a:ln>
                 <a:noFill/>
@@ -320,6 +322,7 @@
             </c:spPr>
           </c:dPt>
           <c:dLbls>
+            <c:numFmt formatCode="#,##0" sourceLinked="0"/>
             <c:spPr>
               <a:noFill/>
               <a:ln>
@@ -334,10 +337,7 @@
                 <a:pPr>
                   <a:defRPr sz="1600" b="1" i="0" u="none" strike="noStrike" kern="1200" baseline="0">
                     <a:solidFill>
-                      <a:schemeClr val="tx1">
-                        <a:lumMod val="65000"/>
-                        <a:lumOff val="35000"/>
-                      </a:schemeClr>
+                      <a:srgbClr val="595959"/>
                     </a:solidFill>
                     <a:latin typeface="Noto Sans" panose="020B0502040504020204" pitchFamily="34" charset="0"/>
                     <a:ea typeface="Noto Sans" panose="020B0502040504020204" pitchFamily="34" charset="0"/>
@@ -429,10 +429,7 @@
           <a:noFill/>
           <a:ln w="9525" cap="flat" cmpd="sng" algn="ctr">
             <a:solidFill>
-              <a:schemeClr val="tx1">
-                <a:lumMod val="15000"/>
-                <a:lumOff val="85000"/>
-              </a:schemeClr>
+              <a:srgbClr val="D9D9D9"/>
             </a:solidFill>
             <a:round/>
           </a:ln>
@@ -445,10 +442,7 @@
             <a:pPr>
               <a:defRPr sz="2000" b="0" i="0" u="none" strike="noStrike" kern="1200" baseline="0">
                 <a:solidFill>
-                  <a:schemeClr val="tx1">
-                    <a:lumMod val="65000"/>
-                    <a:lumOff val="35000"/>
-                  </a:schemeClr>
+                  <a:srgbClr val="595959"/>
                 </a:solidFill>
                 <a:latin typeface="Noto Sans" panose="020B0502040504020204" pitchFamily="34" charset="0"/>
                 <a:ea typeface="Noto Sans" panose="020B0502040504020204" pitchFamily="34" charset="0"/>
@@ -491,10 +485,7 @@
             <a:pPr>
               <a:defRPr sz="2000" b="0" i="0" u="none" strike="noStrike" kern="1200" baseline="0">
                 <a:solidFill>
-                  <a:schemeClr val="tx1">
-                    <a:lumMod val="65000"/>
-                    <a:lumOff val="35000"/>
-                  </a:schemeClr>
+                  <a:srgbClr val="595959"/>
                 </a:solidFill>
                 <a:latin typeface="Noto Sans" panose="020B0502040504020204" pitchFamily="34" charset="0"/>
                 <a:ea typeface="Noto Sans" panose="020B0502040504020204" pitchFamily="34" charset="0"/>
@@ -543,6 +534,363 @@
       <a:endParaRPr lang="en-US"/>
     </a:p>
   </c:txPr>
+</c:chartSpace>
+</file>
+
+<file path=ppt/charts/chart5.xml><?xml version="1.0" encoding="utf-8"?>
+<c:chartSpace xmlns:c="http://schemas.openxmlformats.org/drawingml/2006/chart" xmlns:a="http://schemas.openxmlformats.org/drawingml/2006/main" xmlns:r="http://schemas.openxmlformats.org/officeDocument/2006/relationships">
+  <c:date1904 val="0"/>
+  <c:lang val="en-US"/>
+  <c:roundedCorners val="0"/>
+  <c:chart>
+    <c:title>
+      <c:tx>
+        <c:rich>
+          <a:bodyPr rot="0" spcFirstLastPara="1" vertOverflow="ellipsis" vert="horz" wrap="square" anchor="ctr" anchorCtr="1"/>
+          <a:lstStyle/>
+          <a:p>
+            <a:pPr>
+              <a:defRPr sz="2000" b="0" i="0" u="none" strike="noStrike" kern="1200" spc="0" baseline="0">
+                <a:solidFill>
+                  <a:srgbClr val="595959"/>
+                </a:solidFill>
+                <a:latin typeface="Noto Sans" panose="020B0502040504020204" pitchFamily="34" charset="0"/>
+                <a:ea typeface="Noto Sans" panose="020B0502040504020204" pitchFamily="34" charset="0"/>
+                <a:cs typeface="+mn-cs"/>
+              </a:defRPr>
+            </a:pPr>
+            <a:r>
+              <a:rPr lang="vi-VN" sz="2000" dirty="0"/>
+              <a:t>(tỷ đồng)</a:t>
+            </a:r>
+          </a:p>
+        </c:rich>
+      </c:tx>
+      <c:layout>
+        <c:manualLayout>
+          <c:xMode val="edge"/>
+          <c:yMode val="edge"/>
+          <c:x val="4.5311773634288392E-2"/>
+          <c:y val="5.2450331681392921E-3"/>
+        </c:manualLayout>
+      </c:layout>
+      <c:overlay val="0"/>
+      <c:spPr>
+        <a:noFill/>
+        <a:ln>
+          <a:noFill/>
+        </a:ln>
+        <a:effectLst/>
+      </c:spPr>
+      <c:txPr>
+        <a:bodyPr rot="0" spcFirstLastPara="1" vertOverflow="ellipsis" vert="horz" wrap="square" anchor="ctr" anchorCtr="1"/>
+        <a:lstStyle/>
+        <a:p>
+          <a:pPr>
+            <a:defRPr sz="2000" b="0" i="0" u="none" strike="noStrike" kern="1200" baseline="0">
+              <a:solidFill>
+                <a:srgbClr val="595959"/>
+              </a:solidFill>
+              <a:latin typeface="Noto Sans" panose="020B0502040504020204" pitchFamily="34" charset="0"/>
+              <a:ea typeface="Noto Sans" panose="020B0502040504020204" pitchFamily="34" charset="0"/>
+              <a:cs typeface="+mn-cs"/>
+            </a:defRPr>
+          </a:pPr>
+          <a:endParaRPr lang="en-US"/>
+        </a:p>
+      </c:txPr>
+    </c:title>
+    <c:autoTitleDeleted val="0"/>
+    <c:plotArea>
+      <c:layout/>
+      <c:barChart>
+        <c:barDir val="col"/>
+        <c:grouping val="clustered"/>
+        <c:varyColors val="0"/>
+        <c:ser>
+          <c:idx val="0"/>
+          <c:order val="0"/>
+          <c:tx>
+            <c:strRef>
+              <c:f>Sheet1!$A$2</c:f>
+              <c:strCache>
+                <c:ptCount val="1"/>
+                <c:pt idx="0">
+                  <c:v>LNTT hợp nhất</c:v>
+                </c:pt>
+              </c:strCache>
+            </c:strRef>
+          </c:tx>
+          <c:spPr>
+            <a:solidFill>
+              <a:srgbClr val="F0B26B"/>
+            </a:solidFill>
+            <a:ln>
+              <a:noFill/>
+            </a:ln>
+            <a:effectLst/>
+          </c:spPr>
+          <c:invertIfNegative val="0"/>
+          <c:dPt>
+            <c:idx val="0"/>
+            <c:invertIfNegative val="0"/>
+            <c:bubble3D val="0"/>
+            <c:spPr>
+              <a:solidFill>
+                <a:srgbClr val="F0B26B"/>
+              </a:solidFill>
+              <a:ln>
+                <a:noFill/>
+              </a:ln>
+              <a:effectLst/>
+            </c:spPr>
+          </c:dPt>
+          <c:dPt>
+            <c:idx val="1"/>
+            <c:invertIfNegative val="0"/>
+            <c:bubble3D val="0"/>
+            <c:spPr>
+              <a:solidFill>
+                <a:srgbClr val="F0B26B"/>
+              </a:solidFill>
+              <a:ln>
+                <a:noFill/>
+              </a:ln>
+              <a:effectLst/>
+            </c:spPr>
+          </c:dPt>
+          <c:dPt>
+            <c:idx val="2"/>
+            <c:invertIfNegative val="0"/>
+            <c:bubble3D val="0"/>
+            <c:spPr>
+              <a:solidFill>
+                <a:srgbClr val="043B72"/>
+              </a:solidFill>
+              <a:ln>
+                <a:noFill/>
+              </a:ln>
+              <a:effectLst/>
+            </c:spPr>
+          </c:dPt>
+          <c:dPt>
+            <c:idx val="3"/>
+            <c:invertIfNegative val="0"/>
+            <c:bubble3D val="0"/>
+            <c:spPr>
+              <a:solidFill>
+                <a:srgbClr val="8DC8E8"/>
+              </a:solidFill>
+              <a:ln>
+                <a:noFill/>
+              </a:ln>
+              <a:effectLst/>
+            </c:spPr>
+          </c:dPt>
+          <c:dLbls>
+            <c:numFmt formatCode="#,##0" sourceLinked="0"/>
+            <c:spPr>
+              <a:noFill/>
+              <a:ln>
+                <a:noFill/>
+              </a:ln>
+              <a:effectLst/>
+            </c:spPr>
+            <c:txPr>
+              <a:bodyPr rot="0" spcFirstLastPara="1" vertOverflow="ellipsis" vert="horz" wrap="square" anchor="ctr" anchorCtr="1"/>
+              <a:lstStyle/>
+              <a:p>
+                <a:pPr>
+                  <a:defRPr sz="1600" b="1" i="0" u="none" strike="noStrike" kern="1200" baseline="0">
+                    <a:solidFill>
+                      <a:srgbClr val="595959"/>
+                    </a:solidFill>
+                    <a:latin typeface="Noto Sans" panose="020B0502040504020204" pitchFamily="34" charset="0"/>
+                    <a:ea typeface="Noto Sans" panose="020B0502040504020204" pitchFamily="34" charset="0"/>
+                    <a:cs typeface="+mn-cs"/>
+                  </a:defRPr>
+                </a:pPr>
+                <a:endParaRPr lang="en-US"/>
+              </a:p>
+            </c:txPr>
+            <c:dLblPos val="outEnd"/>
+            <c:showLegendKey val="0"/>
+            <c:showVal val="1"/>
+            <c:showCatName val="0"/>
+            <c:showSerName val="0"/>
+            <c:showPercent val="0"/>
+            <c:showBubbleSize val="0"/>
+          </c:dLbls>
+          <c:cat>
+            <c:strRef>
+              <c:f>Sheet1!$B$1:$E$1</c:f>
+              <c:strCache>
+                <c:ptCount val="4"/>
+                <c:pt idx="0">
+                  <c:v>1H25</c:v>
+                </c:pt>
+                <c:pt idx="1">
+                  <c:v>2H25</c:v>
+                </c:pt>
+                <c:pt idx="2">
+                  <c:v>1H26</c:v>
+                </c:pt>
+                <c:pt idx="3">
+                  <c:v>2H26 cần để đạt KH</c:v>
+                </c:pt>
+              </c:strCache>
+            </c:strRef>
+          </c:cat>
+          <c:val>
+            <c:numRef>
+              <c:f>Sheet1!$B$2:$E$2</c:f>
+              <c:numCache>
+                <c:formatCode>#,##0</c:formatCode>
+                <c:ptCount val="4"/>
+                <c:pt idx="0">
+                  <c:v>11240</c:v>
+                </c:pt>
+                <c:pt idx="1">
+                  <c:v>19360</c:v>
+                </c:pt>
+                <c:pt idx="2">
+                  <c:v>18880</c:v>
+                </c:pt>
+                <c:pt idx="3">
+                  <c:v>22443</c:v>
+                </c:pt>
+              </c:numCache>
+            </c:numRef>
+          </c:val>
+        </c:ser>
+        <c:gapWidth val="70"/>
+        <c:overlap val="-27"/>
+        <c:axId val="811334001"/>
+        <c:axId val="811334002"/>
+      </c:barChart>
+      <c:catAx>
+        <c:axId val="811334001"/>
+        <c:scaling>
+          <c:orientation val="minMax"/>
+        </c:scaling>
+        <c:delete val="0"/>
+        <c:axPos val="b"/>
+        <c:numFmt formatCode="General" sourceLinked="1"/>
+        <c:majorTickMark val="none"/>
+        <c:minorTickMark val="none"/>
+        <c:tickLblPos val="low"/>
+        <c:spPr>
+          <a:noFill/>
+          <a:ln w="9525" cap="flat" cmpd="sng" algn="ctr">
+            <a:solidFill>
+              <a:srgbClr val="D9D9D9"/>
+            </a:solidFill>
+            <a:round/>
+          </a:ln>
+          <a:effectLst/>
+        </c:spPr>
+        <c:txPr>
+          <a:bodyPr rot="-60000000" spcFirstLastPara="1" vertOverflow="ellipsis" vert="horz" wrap="square" anchor="ctr" anchorCtr="1"/>
+          <a:lstStyle/>
+          <a:p>
+            <a:pPr>
+              <a:defRPr sz="1400" b="0" i="0" u="none" strike="noStrike" kern="1200" baseline="0">
+                <a:solidFill>
+                  <a:srgbClr val="595959"/>
+                </a:solidFill>
+                <a:latin typeface="Noto Sans" panose="020B0502040504020204" pitchFamily="34" charset="0"/>
+                <a:ea typeface="Noto Sans" panose="020B0502040504020204" pitchFamily="34" charset="0"/>
+                <a:cs typeface="+mn-cs"/>
+              </a:defRPr>
+            </a:pPr>
+            <a:endParaRPr lang="en-US"/>
+          </a:p>
+        </c:txPr>
+        <c:crossAx val="811334002"/>
+        <c:crosses val="autoZero"/>
+        <c:auto val="1"/>
+        <c:lblAlgn val="ctr"/>
+        <c:lblOffset val="100"/>
+        <c:noMultiLvlLbl val="0"/>
+      </c:catAx>
+      <c:valAx>
+        <c:axId val="811334002"/>
+        <c:scaling>
+          <c:orientation val="minMax"/>
+          <c:min val="0"/>
+        </c:scaling>
+        <c:delete val="0"/>
+        <c:axPos val="l"/>
+        <c:numFmt formatCode="#,##0" sourceLinked="0"/>
+        <c:majorTickMark val="none"/>
+        <c:minorTickMark val="none"/>
+        <c:tickLblPos val="nextTo"/>
+        <c:spPr>
+          <a:noFill/>
+          <a:ln>
+            <a:noFill/>
+          </a:ln>
+          <a:effectLst/>
+        </c:spPr>
+        <c:txPr>
+          <a:bodyPr rot="-60000000" spcFirstLastPara="1" vertOverflow="ellipsis" vert="horz" wrap="square" anchor="ctr" anchorCtr="1"/>
+          <a:lstStyle/>
+          <a:p>
+            <a:pPr>
+              <a:defRPr sz="2000" b="0" i="0" u="none" strike="noStrike" kern="1200" baseline="0">
+                <a:solidFill>
+                  <a:srgbClr val="595959"/>
+                </a:solidFill>
+                <a:latin typeface="Noto Sans" panose="020B0502040504020204" pitchFamily="34" charset="0"/>
+                <a:ea typeface="Noto Sans" panose="020B0502040504020204" pitchFamily="34" charset="0"/>
+                <a:cs typeface="+mn-cs"/>
+              </a:defRPr>
+            </a:pPr>
+            <a:endParaRPr lang="en-US"/>
+          </a:p>
+        </c:txPr>
+        <c:crossAx val="811334001"/>
+        <c:crosses val="autoZero"/>
+        <c:crossBetween val="between"/>
+        <c:majorUnit val="5000"/>
+      </c:valAx>
+      <c:spPr>
+        <a:noFill/>
+        <a:ln>
+          <a:noFill/>
+        </a:ln>
+        <a:effectLst/>
+      </c:spPr>
+    </c:plotArea>
+    <c:plotVisOnly val="1"/>
+    <c:dispBlanksAs val="gap"/>
+    <c:showDLblsOverMax val="0"/>
+  </c:chart>
+  <c:spPr>
+    <a:noFill/>
+    <a:ln w="9525" cap="flat" cmpd="sng" algn="ctr">
+      <a:noFill/>
+      <a:round/>
+    </a:ln>
+    <a:effectLst/>
+  </c:spPr>
+  <c:txPr>
+    <a:bodyPr/>
+    <a:lstStyle/>
+    <a:p>
+      <a:pPr>
+        <a:defRPr sz="2000">
+          <a:latin typeface="Noto Sans" panose="020B0502040504020204" pitchFamily="34" charset="0"/>
+          <a:ea typeface="Noto Sans" panose="020B0502040504020204" pitchFamily="34" charset="0"/>
+          <a:cs typeface="+mn-cs"/>
+        </a:defRPr>
+      </a:pPr>
+      <a:endParaRPr lang="en-US"/>
+    </a:p>
+  </c:txPr>
+  <c:externalData r:id="rId1">
+    <c:autoUpdate val="0"/>
+  </c:externalData>
 </c:chartSpace>
 </file>
 
@@ -9051,6 +9399,539 @@
 </p:sldMaster>
 </file>
 
+<file path=ppt/slides/slide10.xml><?xml version="1.0" encoding="utf-8"?>
+<p:sld xmlns:a="http://schemas.openxmlformats.org/drawingml/2006/main" xmlns:p="http://schemas.openxmlformats.org/presentationml/2006/main" xmlns:r="http://schemas.openxmlformats.org/officeDocument/2006/relationships">
+  <p:cSld>
+    <p:spTree>
+      <p:nvGrpSpPr>
+        <p:cNvPr id="1" name=""/>
+        <p:cNvGrpSpPr/>
+        <p:nvPr/>
+      </p:nvGrpSpPr>
+      <p:grpSpPr/>
+      <p:pic>
+        <p:nvPicPr>
+          <p:cNvPr id="6" name="Picture 5" descr="A white rectangle with pink border&#10;&#10;Description automatically generated">
+            <a:extLst>
+              <a:ext uri="{FF2B5EF4-FFF2-40B4-BE49-F238E27FC236}">
+                <a16:creationId xmlns:a16="http://schemas.microsoft.com/office/drawing/2014/main" id="{E28BF981-17E9-B1F5-F8D5-3BFE81077E0E}"/>
+              </a:ext>
+            </a:extLst>
+          </p:cNvPr>
+          <p:cNvPicPr>
+            <a:picLocks noGrp="1" noRot="1" noChangeAspect="1" noMove="1" noResize="1" noEditPoints="1" noAdjustHandles="1" noChangeArrowheads="1" noChangeShapeType="1" noCrop="1"/>
+          </p:cNvPicPr>
+          <p:nvPr/>
+        </p:nvPicPr>
+        <p:blipFill>
+          <a:blip r:embed="rId2">
+            <a:extLst>
+              <a:ext uri="{28A0092B-C50C-407E-A947-70E740481C1C}">
+                <a14:useLocalDpi xmlns:a14="http://schemas.microsoft.com/office/drawing/2010/main" val="0"/>
+              </a:ext>
+            </a:extLst>
+          </a:blip>
+          <a:stretch>
+            <a:fillRect/>
+          </a:stretch>
+        </p:blipFill>
+        <p:spPr>
+          <a:xfrm>
+            <a:off x="0" y="0"/>
+            <a:ext cx="10287000" cy="13716000"/>
+          </a:xfrm>
+          <a:prstGeom prst="rect">
+            <a:avLst/>
+          </a:prstGeom>
+        </p:spPr>
+      </p:pic>
+      <p:sp>
+        <p:nvSpPr>
+          <p:cNvPr id="4" name="Freeform: Shape 3">
+            <a:extLst>
+              <a:ext uri="{FF2B5EF4-FFF2-40B4-BE49-F238E27FC236}">
+                <a16:creationId xmlns:a16="http://schemas.microsoft.com/office/drawing/2014/main" id="{55EAFF75-477A-37F1-48F6-130C019EA774}"/>
+              </a:ext>
+            </a:extLst>
+          </p:cNvPr>
+          <p:cNvSpPr/>
+          <p:nvPr/>
+        </p:nvSpPr>
+        <p:spPr>
+          <a:xfrm>
+            <a:off x="586534" y="668818"/>
+            <a:ext cx="9113926" cy="1177680"/>
+          </a:xfrm>
+          <a:custGeom>
+            <a:avLst/>
+            <a:gdLst>
+              <a:gd name="connsiteX0" fmla="*/ 525894 w 9113926"/>
+              <a:gd name="connsiteY0" fmla="*/ 0 h 1177680"/>
+              <a:gd name="connsiteX1" fmla="*/ 8588032 w 9113926"/>
+              <a:gd name="connsiteY1" fmla="*/ 0 h 1177680"/>
+              <a:gd name="connsiteX2" fmla="*/ 9113925 w 9113926"/>
+              <a:gd name="connsiteY2" fmla="*/ 525893 h 1177680"/>
+              <a:gd name="connsiteX3" fmla="*/ 9113925 w 9113926"/>
+              <a:gd name="connsiteY3" fmla="*/ 609084 h 1177680"/>
+              <a:gd name="connsiteX4" fmla="*/ 9113926 w 9113926"/>
+              <a:gd name="connsiteY4" fmla="*/ 609084 h 1177680"/>
+              <a:gd name="connsiteX5" fmla="*/ 9113926 w 9113926"/>
+              <a:gd name="connsiteY5" fmla="*/ 1177679 h 1177680"/>
+              <a:gd name="connsiteX6" fmla="*/ 8588042 w 9113926"/>
+              <a:gd name="connsiteY6" fmla="*/ 1177679 h 1177680"/>
+              <a:gd name="connsiteX7" fmla="*/ 8588032 w 9113926"/>
+              <a:gd name="connsiteY7" fmla="*/ 1177680 h 1177680"/>
+              <a:gd name="connsiteX8" fmla="*/ 525894 w 9113926"/>
+              <a:gd name="connsiteY8" fmla="*/ 1177680 h 1177680"/>
+              <a:gd name="connsiteX9" fmla="*/ 525884 w 9113926"/>
+              <a:gd name="connsiteY9" fmla="*/ 1177679 h 1177680"/>
+              <a:gd name="connsiteX10" fmla="*/ 0 w 9113926"/>
+              <a:gd name="connsiteY10" fmla="*/ 1177679 h 1177680"/>
+              <a:gd name="connsiteX11" fmla="*/ 0 w 9113926"/>
+              <a:gd name="connsiteY11" fmla="*/ 609084 h 1177680"/>
+              <a:gd name="connsiteX12" fmla="*/ 1 w 9113926"/>
+              <a:gd name="connsiteY12" fmla="*/ 609084 h 1177680"/>
+              <a:gd name="connsiteX13" fmla="*/ 1 w 9113926"/>
+              <a:gd name="connsiteY13" fmla="*/ 525893 h 1177680"/>
+              <a:gd name="connsiteX14" fmla="*/ 525894 w 9113926"/>
+              <a:gd name="connsiteY14" fmla="*/ 0 h 1177680"/>
+            </a:gdLst>
+            <a:ahLst/>
+            <a:cxnLst>
+              <a:cxn ang="0">
+                <a:pos x="connsiteX0" y="connsiteY0"/>
+              </a:cxn>
+              <a:cxn ang="0">
+                <a:pos x="connsiteX1" y="connsiteY1"/>
+              </a:cxn>
+              <a:cxn ang="0">
+                <a:pos x="connsiteX2" y="connsiteY2"/>
+              </a:cxn>
+              <a:cxn ang="0">
+                <a:pos x="connsiteX3" y="connsiteY3"/>
+              </a:cxn>
+              <a:cxn ang="0">
+                <a:pos x="connsiteX4" y="connsiteY4"/>
+              </a:cxn>
+              <a:cxn ang="0">
+                <a:pos x="connsiteX5" y="connsiteY5"/>
+              </a:cxn>
+              <a:cxn ang="0">
+                <a:pos x="connsiteX6" y="connsiteY6"/>
+              </a:cxn>
+              <a:cxn ang="0">
+                <a:pos x="connsiteX7" y="connsiteY7"/>
+              </a:cxn>
+              <a:cxn ang="0">
+                <a:pos x="connsiteX8" y="connsiteY8"/>
+              </a:cxn>
+              <a:cxn ang="0">
+                <a:pos x="connsiteX9" y="connsiteY9"/>
+              </a:cxn>
+              <a:cxn ang="0">
+                <a:pos x="connsiteX10" y="connsiteY10"/>
+              </a:cxn>
+              <a:cxn ang="0">
+                <a:pos x="connsiteX11" y="connsiteY11"/>
+              </a:cxn>
+              <a:cxn ang="0">
+                <a:pos x="connsiteX12" y="connsiteY12"/>
+              </a:cxn>
+              <a:cxn ang="0">
+                <a:pos x="connsiteX13" y="connsiteY13"/>
+              </a:cxn>
+              <a:cxn ang="0">
+                <a:pos x="connsiteX14" y="connsiteY14"/>
+              </a:cxn>
+            </a:cxnLst>
+            <a:rect l="l" t="t" r="r" b="b"/>
+            <a:pathLst>
+              <a:path w="9113926" h="1177680">
+                <a:moveTo>
+                  <a:pt x="525894" y="0"/>
+                </a:moveTo>
+                <a:lnTo>
+                  <a:pt x="8588032" y="0"/>
+                </a:lnTo>
+                <a:cubicBezTo>
+                  <a:pt x="8878475" y="0"/>
+                  <a:pt x="9113925" y="235450"/>
+                  <a:pt x="9113925" y="525893"/>
+                </a:cubicBezTo>
+                <a:lnTo>
+                  <a:pt x="9113925" y="609084"/>
+                </a:lnTo>
+                <a:lnTo>
+                  <a:pt x="9113926" y="609084"/>
+                </a:lnTo>
+                <a:lnTo>
+                  <a:pt x="9113926" y="1177679"/>
+                </a:lnTo>
+                <a:lnTo>
+                  <a:pt x="8588042" y="1177679"/>
+                </a:lnTo>
+                <a:lnTo>
+                  <a:pt x="8588032" y="1177680"/>
+                </a:lnTo>
+                <a:lnTo>
+                  <a:pt x="525894" y="1177680"/>
+                </a:lnTo>
+                <a:lnTo>
+                  <a:pt x="525884" y="1177679"/>
+                </a:lnTo>
+                <a:lnTo>
+                  <a:pt x="0" y="1177679"/>
+                </a:lnTo>
+                <a:lnTo>
+                  <a:pt x="0" y="609084"/>
+                </a:lnTo>
+                <a:lnTo>
+                  <a:pt x="1" y="609084"/>
+                </a:lnTo>
+                <a:lnTo>
+                  <a:pt x="1" y="525893"/>
+                </a:lnTo>
+                <a:cubicBezTo>
+                  <a:pt x="1" y="235450"/>
+                  <a:pt x="235451" y="0"/>
+                  <a:pt x="525894" y="0"/>
+                </a:cubicBezTo>
+                <a:close/>
+              </a:path>
+            </a:pathLst>
+          </a:custGeom>
+          <a:gradFill>
+            <a:gsLst>
+              <a:gs pos="0">
+                <a:srgbClr val="F48120"/>
+              </a:gs>
+              <a:gs pos="100000">
+                <a:srgbClr val="FE6700"/>
+              </a:gs>
+            </a:gsLst>
+            <a:lin ang="5400000" scaled="1"/>
+          </a:gradFill>
+          <a:ln>
+            <a:solidFill>
+              <a:srgbClr val="FFE6AB"/>
+            </a:solidFill>
+          </a:ln>
+        </p:spPr>
+        <p:style>
+          <a:lnRef idx="2">
+            <a:schemeClr val="accent1">
+              <a:shade val="15000"/>
+            </a:schemeClr>
+          </a:lnRef>
+          <a:fillRef idx="1">
+            <a:schemeClr val="accent1"/>
+          </a:fillRef>
+          <a:effectRef idx="0">
+            <a:schemeClr val="accent1"/>
+          </a:effectRef>
+          <a:fontRef idx="minor">
+            <a:schemeClr val="lt1"/>
+          </a:fontRef>
+        </p:style>
+        <p:txBody>
+          <a:bodyPr wrap="square" rtlCol="0" anchor="ctr">
+            <a:noAutofit/>
+          </a:bodyPr>
+          <a:lstStyle/>
+          <a:p>
+            <a:pPr algn="ctr"/>
+            <a:endParaRPr lang="en-US" dirty="0"/>
+          </a:p>
+        </p:txBody>
+      </p:sp>
+      <p:sp>
+        <p:nvSpPr>
+          <p:cNvPr id="9" name="TextBox 8">
+            <a:extLst>
+              <a:ext uri="{FF2B5EF4-FFF2-40B4-BE49-F238E27FC236}">
+                <a16:creationId xmlns:a16="http://schemas.microsoft.com/office/drawing/2014/main" id="{743DB708-16AB-33EF-48F6-9A48114CA976}"/>
+              </a:ext>
+            </a:extLst>
+          </p:cNvPr>
+          <p:cNvSpPr txBox="1"/>
+          <p:nvPr/>
+        </p:nvSpPr>
+        <p:spPr>
+          <a:xfrm>
+            <a:off x="586539" y="928966"/>
+            <a:ext cx="9113922" cy="707886"/>
+          </a:xfrm>
+          <a:prstGeom prst="rect">
+            <a:avLst/>
+          </a:prstGeom>
+          <a:noFill/>
+        </p:spPr>
+        <p:txBody>
+          <a:bodyPr wrap="square" rtlCol="0">
+            <a:spAutoFit/>
+          </a:bodyPr>
+          <a:lstStyle/>
+          <a:p>
+            <a:pPr algn="ctr"/>
+            <a:r>
+              <a:rPr lang="en-US" sz="4000" dirty="0">
+                <a:solidFill>
+                  <a:schemeClr val="bg1"/>
+                </a:solidFill>
+                <a:latin typeface="SVN-Gilroy XBold" panose="00000900000000000000" pitchFamily="50" charset="0"/>
+              </a:rPr>
+              <a:t>VPB – Nền so sánh nửa cuối năm là điểm cần lưu ý</a:t>
+            </a:r>
+            <a:endParaRPr lang="vi-VN" sz="4000" dirty="0">
+              <a:solidFill>
+                <a:schemeClr val="bg1"/>
+              </a:solidFill>
+              <a:latin typeface="SVN-Gilroy XBold" panose="00000900000000000000" pitchFamily="50" charset="0"/>
+            </a:endParaRPr>
+          </a:p>
+        </p:txBody>
+      </p:sp>
+      <p:sp>
+        <p:nvSpPr>
+          <p:cNvPr id="2" name="TextBox 1">
+            <a:extLst>
+              <a:ext uri="{FF2B5EF4-FFF2-40B4-BE49-F238E27FC236}">
+                <a16:creationId xmlns:a16="http://schemas.microsoft.com/office/drawing/2014/main" id="{70BB23A5-EC1E-341E-EF08-A57BD2521AED}"/>
+              </a:ext>
+            </a:extLst>
+          </p:cNvPr>
+          <p:cNvSpPr txBox="1"/>
+          <p:nvPr/>
+        </p:nvSpPr>
+        <p:spPr>
+          <a:xfrm>
+            <a:off x="1429871" y="11654118"/>
+            <a:ext cx="7440705" cy="923330"/>
+          </a:xfrm>
+          <a:prstGeom prst="rect">
+            <a:avLst/>
+          </a:prstGeom>
+          <a:noFill/>
+        </p:spPr>
+        <p:txBody>
+          <a:bodyPr wrap="square" rtlCol="0">
+            <a:spAutoFit/>
+          </a:bodyPr>
+          <a:lstStyle/>
+          <a:p>
+            <a:r>
+              <a:rPr lang="en-US" dirty="0" err="1"/>
+              <a:t>Nguồn: VPBank, MAS tổng hợp. 1H25 và 2H25 suy ra từ LNTT cả năm 2025 (30,600 tỷ) và mức tăng 68% của 1H26. Cột 2H26 là mức cần đạt để hoàn thành kế hoạch 41,323 tỷ, không phải dự phóng của MAS.</a:t>
+            </a:r>
+            <a:r>
+              <a:rPr lang="en-US" dirty="0"/>
+              <a:t/>
+            </a:r>
+            <a:r>
+              <a:rPr lang="en-US" dirty="0" err="1"/>
+              <a:t/>
+            </a:r>
+            <a:r>
+              <a:rPr lang="en-US" dirty="0"/>
+              <a:t/>
+            </a:r>
+            <a:r>
+              <a:rPr lang="en-US" dirty="0" err="1"/>
+              <a:t/>
+            </a:r>
+            <a:r>
+              <a:rPr lang="en-US" dirty="0"/>
+              <a:t/>
+            </a:r>
+            <a:r>
+              <a:rPr lang="en-US" dirty="0" err="1"/>
+              <a:t/>
+            </a:r>
+            <a:r>
+              <a:rPr lang="en-US" dirty="0"/>
+              <a:t/>
+            </a:r>
+            <a:r>
+              <a:rPr lang="en-US" dirty="0" err="1"/>
+              <a:t/>
+            </a:r>
+            <a:r>
+              <a:rPr lang="en-US" dirty="0"/>
+              <a:t/>
+            </a:r>
+            <a:r>
+              <a:rPr lang="en-US" dirty="0" err="1"/>
+              <a:t/>
+            </a:r>
+            <a:r>
+              <a:rPr lang="en-US" dirty="0"/>
+              <a:t/>
+            </a:r>
+            <a:r>
+              <a:rPr lang="en-US" dirty="0" err="1"/>
+              <a:t/>
+            </a:r>
+            <a:r>
+              <a:rPr lang="en-US" dirty="0"/>
+              <a:t/>
+            </a:r>
+            <a:r>
+              <a:rPr lang="en-US" dirty="0" err="1"/>
+              <a:t/>
+            </a:r>
+            <a:r>
+              <a:rPr lang="en-US" dirty="0"/>
+              <a:t/>
+            </a:r>
+            <a:r>
+              <a:rPr lang="en-US" dirty="0" err="1"/>
+              <a:t/>
+            </a:r>
+            <a:r>
+              <a:rPr lang="en-US" dirty="0"/>
+              <a:t/>
+            </a:r>
+            <a:r>
+              <a:rPr lang="en-US" dirty="0" err="1"/>
+              <a:t/>
+            </a:r>
+            <a:r>
+              <a:rPr lang="en-US" dirty="0"/>
+              <a:t/>
+            </a:r>
+            <a:r>
+              <a:rPr lang="en-US" dirty="0" err="1"/>
+              <a:t/>
+            </a:r>
+            <a:r>
+              <a:rPr lang="en-US" dirty="0"/>
+              <a:t/>
+            </a:r>
+            <a:r>
+              <a:rPr lang="en-US" dirty="0" err="1"/>
+              <a:t/>
+            </a:r>
+            <a:r>
+              <a:rPr lang="en-US" dirty="0"/>
+              <a:t/>
+            </a:r>
+            <a:r>
+              <a:rPr lang="en-US" dirty="0" err="1"/>
+              <a:t/>
+            </a:r>
+            <a:r>
+              <a:rPr lang="en-US" dirty="0"/>
+              <a:t/>
+            </a:r>
+            <a:r>
+              <a:rPr lang="en-US" dirty="0" err="1"/>
+              <a:t/>
+            </a:r>
+            <a:r>
+              <a:rPr lang="en-US" dirty="0"/>
+              <a:t/>
+            </a:r>
+            <a:r>
+              <a:rPr lang="en-US" dirty="0" err="1"/>
+              <a:t/>
+            </a:r>
+            <a:r>
+              <a:rPr lang="en-US" dirty="0"/>
+              <a:t/>
+            </a:r>
+            <a:r>
+              <a:rPr lang="en-US" dirty="0" err="1"/>
+              <a:t/>
+            </a:r>
+            <a:r>
+              <a:rPr lang="en-US" dirty="0"/>
+              <a:t/>
+            </a:r>
+            <a:r>
+              <a:rPr lang="en-US" dirty="0" err="1"/>
+              <a:t/>
+            </a:r>
+            <a:r>
+              <a:rPr lang="en-US" dirty="0"/>
+              <a:t/>
+            </a:r>
+            <a:r>
+              <a:rPr lang="en-US" dirty="0" err="1"/>
+              <a:t/>
+            </a:r>
+            <a:r>
+              <a:rPr lang="en-US" dirty="0"/>
+              <a:t/>
+            </a:r>
+            <a:r>
+              <a:rPr lang="en-US" dirty="0" err="1"/>
+              <a:t/>
+            </a:r>
+            <a:r>
+              <a:rPr lang="en-US" dirty="0"/>
+              <a:t/>
+            </a:r>
+            <a:r>
+              <a:rPr lang="en-US" dirty="0" err="1"/>
+              <a:t/>
+            </a:r>
+            <a:r>
+              <a:rPr lang="en-US" dirty="0"/>
+              <a:t/>
+            </a:r>
+            <a:r>
+              <a:rPr lang="en-US" dirty="0" err="1"/>
+              <a:t/>
+            </a:r>
+            <a:r>
+              <a:rPr lang="en-US" dirty="0"/>
+              <a:t/>
+            </a:r>
+            <a:r>
+              <a:rPr lang="en-US" dirty="0" err="1"/>
+              <a:t/>
+            </a:r>
+            <a:r>
+              <a:rPr lang="en-US" dirty="0"/>
+              <a:t/>
+            </a:r>
+            <a:r>
+              <a:rPr lang="en-US" dirty="0" err="1"/>
+              <a:t/>
+            </a:r>
+            <a:r>
+              <a:rPr lang="en-US" dirty="0"/>
+              <a:t/>
+            </a:r>
+          </a:p>
+        </p:txBody>
+      </p:sp>
+      <p:graphicFrame>
+        <p:nvGraphicFramePr>
+          <p:cNvPr id="10" name="Chart 9"/>
+          <p:cNvGraphicFramePr>
+            <a:graphicFrameLocks noGrp="1"/>
+          </p:cNvGraphicFramePr>
+          <p:nvPr/>
+        </p:nvGraphicFramePr>
+        <p:xfrm>
+          <a:off x="1650999" y="2514600"/>
+          <a:ext cx="7543800" cy="9271000"/>
+        </p:xfrm>
+        <a:graphic>
+          <a:graphicData uri="http://schemas.openxmlformats.org/drawingml/2006/chart">
+            <c:chart xmlns:c="http://schemas.openxmlformats.org/drawingml/2006/chart" r:id="rId3"/>
+          </a:graphicData>
+        </a:graphic>
+      </p:graphicFrame>
+    </p:spTree>
+  </p:cSld>
+  <p:clrMapOvr>
+    <a:masterClrMapping/>
+  </p:clrMapOvr>
+</p:sld>
+</file>
+
 <file path=ppt/slides/slide5.xml><?xml version="1.0" encoding="utf-8"?>
 <p:sld xmlns:a="http://schemas.openxmlformats.org/drawingml/2006/main" xmlns:r="http://schemas.openxmlformats.org/officeDocument/2006/relationships" xmlns:p="http://schemas.openxmlformats.org/presentationml/2006/main">
   <p:cSld>

</xml_diff>